<commit_message>
the weights of mid-sem test and final exam have been updated in week 1 slides
</commit_message>
<xml_diff>
--- a/Live-lecture-slides/CITS5503CloudComputingIntro_week1.pptx
+++ b/Live-lecture-slides/CITS5503CloudComputingIntro_week1.pptx
@@ -14031,7 +14031,7 @@
               <a:rPr lang="en-AU" sz="2000" dirty="0">
                 <a:cs typeface="Arial" panose="020B0604020202020204" pitchFamily="34" charset="0"/>
               </a:rPr>
-              <a:t>Mid-semester test is worth 30% of the unit grade (more details later)</a:t>
+              <a:t>Mid-semester test is worth 20% of the unit grade (more details later)</a:t>
             </a:r>
           </a:p>
           <a:p>
@@ -14039,7 +14039,19 @@
               <a:rPr lang="en-AU" sz="2000" dirty="0">
                 <a:cs typeface="Arial" panose="020B0604020202020204" pitchFamily="34" charset="0"/>
               </a:rPr>
-              <a:t>Final Exam: 50% of the unit grade.</a:t>
+              <a:t>Final Exam</a:t>
+            </a:r>
+            <a:r>
+              <a:rPr lang="en-AU" sz="2000">
+                <a:cs typeface="Arial" panose="020B0604020202020204" pitchFamily="34" charset="0"/>
+              </a:rPr>
+              <a:t>: 60</a:t>
+            </a:r>
+            <a:r>
+              <a:rPr lang="en-AU" sz="2000" dirty="0">
+                <a:cs typeface="Arial" panose="020B0604020202020204" pitchFamily="34" charset="0"/>
+              </a:rPr>
+              <a:t>% of the unit grade.</a:t>
             </a:r>
           </a:p>
           <a:p>
@@ -14841,7 +14853,7 @@
           </a:ln>
           <a:extLst>
             <a:ext uri="{C572A759-6A51-4108-AA02-DFA0A04FC94B}">
-              <ma14:wrappingTextBoxFlag xmlns="" xmlns:m="http://schemas.openxmlformats.org/officeDocument/2006/math" xmlns:a14="http://schemas.microsoft.com/office/drawing/2010/main" xmlns:ma14="http://schemas.microsoft.com/office/mac/drawingml/2011/main" val="1"/>
+              <ma14:wrappingTextBoxFlag xmlns:ma14="http://schemas.microsoft.com/office/mac/drawingml/2011/main" xmlns:a14="http://schemas.microsoft.com/office/drawing/2010/main" xmlns:m="http://schemas.openxmlformats.org/officeDocument/2006/math" xmlns="" val="1"/>
             </a:ext>
           </a:extLst>
         </p:spPr>
@@ -15410,7 +15422,7 @@
           </a:ln>
           <a:extLst>
             <a:ext uri="{C572A759-6A51-4108-AA02-DFA0A04FC94B}">
-              <ma14:wrappingTextBoxFlag xmlns="" xmlns:m="http://schemas.openxmlformats.org/officeDocument/2006/math" xmlns:a14="http://schemas.microsoft.com/office/drawing/2010/main" xmlns:ma14="http://schemas.microsoft.com/office/mac/drawingml/2011/main" val="1"/>
+              <ma14:wrappingTextBoxFlag xmlns:ma14="http://schemas.microsoft.com/office/mac/drawingml/2011/main" xmlns:a14="http://schemas.microsoft.com/office/drawing/2010/main" xmlns:m="http://schemas.openxmlformats.org/officeDocument/2006/math" xmlns="" val="1"/>
             </a:ext>
           </a:extLst>
         </p:spPr>
@@ -15740,7 +15752,7 @@
           </a:ln>
           <a:extLst>
             <a:ext uri="{C572A759-6A51-4108-AA02-DFA0A04FC94B}">
-              <ma14:wrappingTextBoxFlag xmlns="" xmlns:m="http://schemas.openxmlformats.org/officeDocument/2006/math" xmlns:a14="http://schemas.microsoft.com/office/drawing/2010/main" xmlns:ma14="http://schemas.microsoft.com/office/mac/drawingml/2011/main" val="1"/>
+              <ma14:wrappingTextBoxFlag xmlns:ma14="http://schemas.microsoft.com/office/mac/drawingml/2011/main" xmlns:a14="http://schemas.microsoft.com/office/drawing/2010/main" xmlns:m="http://schemas.openxmlformats.org/officeDocument/2006/math" xmlns="" val="1"/>
             </a:ext>
           </a:extLst>
         </p:spPr>
@@ -16084,7 +16096,7 @@
           </a:ln>
           <a:extLst>
             <a:ext uri="{C572A759-6A51-4108-AA02-DFA0A04FC94B}">
-              <ma14:wrappingTextBoxFlag xmlns="" xmlns:m="http://schemas.openxmlformats.org/officeDocument/2006/math" xmlns:a14="http://schemas.microsoft.com/office/drawing/2010/main" xmlns:ma14="http://schemas.microsoft.com/office/mac/drawingml/2011/main" val="1"/>
+              <ma14:wrappingTextBoxFlag xmlns:ma14="http://schemas.microsoft.com/office/mac/drawingml/2011/main" xmlns:a14="http://schemas.microsoft.com/office/drawing/2010/main" xmlns:m="http://schemas.openxmlformats.org/officeDocument/2006/math" xmlns="" val="1"/>
             </a:ext>
           </a:extLst>
         </p:spPr>
@@ -16439,7 +16451,7 @@
           </a:ln>
           <a:extLst>
             <a:ext uri="{C572A759-6A51-4108-AA02-DFA0A04FC94B}">
-              <ma14:wrappingTextBoxFlag xmlns="" xmlns:m="http://schemas.openxmlformats.org/officeDocument/2006/math" xmlns:a14="http://schemas.microsoft.com/office/drawing/2010/main" xmlns:ma14="http://schemas.microsoft.com/office/mac/drawingml/2011/main" val="1"/>
+              <ma14:wrappingTextBoxFlag xmlns:ma14="http://schemas.microsoft.com/office/mac/drawingml/2011/main" xmlns:a14="http://schemas.microsoft.com/office/drawing/2010/main" xmlns:m="http://schemas.openxmlformats.org/officeDocument/2006/math" xmlns="" val="1"/>
             </a:ext>
           </a:extLst>
         </p:spPr>
@@ -16802,7 +16814,7 @@
           </a:ln>
           <a:extLst>
             <a:ext uri="{C572A759-6A51-4108-AA02-DFA0A04FC94B}">
-              <ma14:wrappingTextBoxFlag xmlns="" xmlns:m="http://schemas.openxmlformats.org/officeDocument/2006/math" xmlns:a14="http://schemas.microsoft.com/office/drawing/2010/main" xmlns:ma14="http://schemas.microsoft.com/office/mac/drawingml/2011/main" val="1"/>
+              <ma14:wrappingTextBoxFlag xmlns:ma14="http://schemas.microsoft.com/office/mac/drawingml/2011/main" xmlns:a14="http://schemas.microsoft.com/office/drawing/2010/main" xmlns:m="http://schemas.openxmlformats.org/officeDocument/2006/math" xmlns="" val="1"/>
             </a:ext>
           </a:extLst>
         </p:spPr>
@@ -16850,7 +16862,7 @@
           </a:ln>
           <a:extLst>
             <a:ext uri="{C572A759-6A51-4108-AA02-DFA0A04FC94B}">
-              <ma14:wrappingTextBoxFlag xmlns="" xmlns:m="http://schemas.openxmlformats.org/officeDocument/2006/math" xmlns:a14="http://schemas.microsoft.com/office/drawing/2010/main" xmlns:ma14="http://schemas.microsoft.com/office/mac/drawingml/2011/main" val="1"/>
+              <ma14:wrappingTextBoxFlag xmlns:ma14="http://schemas.microsoft.com/office/mac/drawingml/2011/main" xmlns:a14="http://schemas.microsoft.com/office/drawing/2010/main" xmlns:m="http://schemas.openxmlformats.org/officeDocument/2006/math" xmlns="" val="1"/>
             </a:ext>
           </a:extLst>
         </p:spPr>
@@ -16898,7 +16910,7 @@
           </a:ln>
           <a:extLst>
             <a:ext uri="{C572A759-6A51-4108-AA02-DFA0A04FC94B}">
-              <ma14:wrappingTextBoxFlag xmlns="" xmlns:m="http://schemas.openxmlformats.org/officeDocument/2006/math" xmlns:a14="http://schemas.microsoft.com/office/drawing/2010/main" xmlns:ma14="http://schemas.microsoft.com/office/mac/drawingml/2011/main" val="1"/>
+              <ma14:wrappingTextBoxFlag xmlns:ma14="http://schemas.microsoft.com/office/mac/drawingml/2011/main" xmlns:a14="http://schemas.microsoft.com/office/drawing/2010/main" xmlns:m="http://schemas.openxmlformats.org/officeDocument/2006/math" xmlns="" val="1"/>
             </a:ext>
           </a:extLst>
         </p:spPr>
@@ -17370,7 +17382,7 @@
           </a:ln>
           <a:extLst>
             <a:ext uri="{C572A759-6A51-4108-AA02-DFA0A04FC94B}">
-              <ma14:wrappingTextBoxFlag xmlns="" xmlns:m="http://schemas.openxmlformats.org/officeDocument/2006/math" xmlns:a14="http://schemas.microsoft.com/office/drawing/2010/main" xmlns:ma14="http://schemas.microsoft.com/office/mac/drawingml/2011/main" val="1"/>
+              <ma14:wrappingTextBoxFlag xmlns:ma14="http://schemas.microsoft.com/office/mac/drawingml/2011/main" xmlns:a14="http://schemas.microsoft.com/office/drawing/2010/main" xmlns:m="http://schemas.openxmlformats.org/officeDocument/2006/math" xmlns="" val="1"/>
             </a:ext>
           </a:extLst>
         </p:spPr>
@@ -17436,7 +17448,7 @@
           </a:ln>
           <a:extLst>
             <a:ext uri="{C572A759-6A51-4108-AA02-DFA0A04FC94B}">
-              <ma14:wrappingTextBoxFlag xmlns="" xmlns:m="http://schemas.openxmlformats.org/officeDocument/2006/math" xmlns:a14="http://schemas.microsoft.com/office/drawing/2010/main" xmlns:ma14="http://schemas.microsoft.com/office/mac/drawingml/2011/main" val="1"/>
+              <ma14:wrappingTextBoxFlag xmlns:ma14="http://schemas.microsoft.com/office/mac/drawingml/2011/main" xmlns:a14="http://schemas.microsoft.com/office/drawing/2010/main" xmlns:m="http://schemas.openxmlformats.org/officeDocument/2006/math" xmlns="" val="1"/>
             </a:ext>
           </a:extLst>
         </p:spPr>
@@ -17516,7 +17528,7 @@
           </a:ln>
           <a:extLst>
             <a:ext uri="{C572A759-6A51-4108-AA02-DFA0A04FC94B}">
-              <ma14:wrappingTextBoxFlag xmlns="" xmlns:m="http://schemas.openxmlformats.org/officeDocument/2006/math" xmlns:a14="http://schemas.microsoft.com/office/drawing/2010/main" xmlns:ma14="http://schemas.microsoft.com/office/mac/drawingml/2011/main" val="1"/>
+              <ma14:wrappingTextBoxFlag xmlns:ma14="http://schemas.microsoft.com/office/mac/drawingml/2011/main" xmlns:a14="http://schemas.microsoft.com/office/drawing/2010/main" xmlns:m="http://schemas.openxmlformats.org/officeDocument/2006/math" xmlns="" val="1"/>
             </a:ext>
           </a:extLst>
         </p:spPr>
@@ -17601,7 +17613,7 @@
           </a:ln>
           <a:extLst>
             <a:ext uri="{C572A759-6A51-4108-AA02-DFA0A04FC94B}">
-              <ma14:wrappingTextBoxFlag xmlns="" xmlns:m="http://schemas.openxmlformats.org/officeDocument/2006/math" xmlns:a14="http://schemas.microsoft.com/office/drawing/2010/main" xmlns:ma14="http://schemas.microsoft.com/office/mac/drawingml/2011/main" val="1"/>
+              <ma14:wrappingTextBoxFlag xmlns:ma14="http://schemas.microsoft.com/office/mac/drawingml/2011/main" xmlns:a14="http://schemas.microsoft.com/office/drawing/2010/main" xmlns:m="http://schemas.openxmlformats.org/officeDocument/2006/math" xmlns="" val="1"/>
             </a:ext>
           </a:extLst>
         </p:spPr>
@@ -18089,7 +18101,7 @@
           </a:ln>
           <a:extLst>
             <a:ext uri="{C572A759-6A51-4108-AA02-DFA0A04FC94B}">
-              <ma14:wrappingTextBoxFlag xmlns="" xmlns:m="http://schemas.openxmlformats.org/officeDocument/2006/math" xmlns:a14="http://schemas.microsoft.com/office/drawing/2010/main" xmlns:ma14="http://schemas.microsoft.com/office/mac/drawingml/2011/main" val="1"/>
+              <ma14:wrappingTextBoxFlag xmlns:ma14="http://schemas.microsoft.com/office/mac/drawingml/2011/main" xmlns:a14="http://schemas.microsoft.com/office/drawing/2010/main" xmlns:m="http://schemas.openxmlformats.org/officeDocument/2006/math" xmlns="" val="1"/>
             </a:ext>
           </a:extLst>
         </p:spPr>
@@ -18137,7 +18149,7 @@
           </a:ln>
           <a:extLst>
             <a:ext uri="{C572A759-6A51-4108-AA02-DFA0A04FC94B}">
-              <ma14:wrappingTextBoxFlag xmlns="" xmlns:m="http://schemas.openxmlformats.org/officeDocument/2006/math" xmlns:a14="http://schemas.microsoft.com/office/drawing/2010/main" xmlns:ma14="http://schemas.microsoft.com/office/mac/drawingml/2011/main" val="1"/>
+              <ma14:wrappingTextBoxFlag xmlns:ma14="http://schemas.microsoft.com/office/mac/drawingml/2011/main" xmlns:a14="http://schemas.microsoft.com/office/drawing/2010/main" xmlns:m="http://schemas.openxmlformats.org/officeDocument/2006/math" xmlns="" val="1"/>
             </a:ext>
           </a:extLst>
         </p:spPr>
@@ -18185,7 +18197,7 @@
           </a:ln>
           <a:extLst>
             <a:ext uri="{C572A759-6A51-4108-AA02-DFA0A04FC94B}">
-              <ma14:wrappingTextBoxFlag xmlns="" xmlns:m="http://schemas.openxmlformats.org/officeDocument/2006/math" xmlns:a14="http://schemas.microsoft.com/office/drawing/2010/main" xmlns:ma14="http://schemas.microsoft.com/office/mac/drawingml/2011/main" val="1"/>
+              <ma14:wrappingTextBoxFlag xmlns:ma14="http://schemas.microsoft.com/office/mac/drawingml/2011/main" xmlns:a14="http://schemas.microsoft.com/office/drawing/2010/main" xmlns:m="http://schemas.openxmlformats.org/officeDocument/2006/math" xmlns="" val="1"/>
             </a:ext>
           </a:extLst>
         </p:spPr>
@@ -18233,7 +18245,7 @@
           </a:ln>
           <a:extLst>
             <a:ext uri="{C572A759-6A51-4108-AA02-DFA0A04FC94B}">
-              <ma14:wrappingTextBoxFlag xmlns="" xmlns:m="http://schemas.openxmlformats.org/officeDocument/2006/math" xmlns:a14="http://schemas.microsoft.com/office/drawing/2010/main" xmlns:ma14="http://schemas.microsoft.com/office/mac/drawingml/2011/main" val="1"/>
+              <ma14:wrappingTextBoxFlag xmlns:ma14="http://schemas.microsoft.com/office/mac/drawingml/2011/main" xmlns:a14="http://schemas.microsoft.com/office/drawing/2010/main" xmlns:m="http://schemas.openxmlformats.org/officeDocument/2006/math" xmlns="" val="1"/>
             </a:ext>
           </a:extLst>
         </p:spPr>
@@ -18593,7 +18605,7 @@
           </a:ln>
           <a:extLst>
             <a:ext uri="{C572A759-6A51-4108-AA02-DFA0A04FC94B}">
-              <ma14:wrappingTextBoxFlag xmlns="" xmlns:m="http://schemas.openxmlformats.org/officeDocument/2006/math" xmlns:a14="http://schemas.microsoft.com/office/drawing/2010/main" xmlns:ma14="http://schemas.microsoft.com/office/mac/drawingml/2011/main" val="1"/>
+              <ma14:wrappingTextBoxFlag xmlns:ma14="http://schemas.microsoft.com/office/mac/drawingml/2011/main" xmlns:a14="http://schemas.microsoft.com/office/drawing/2010/main" xmlns:m="http://schemas.openxmlformats.org/officeDocument/2006/math" xmlns="" val="1"/>
             </a:ext>
           </a:extLst>
         </p:spPr>
@@ -18668,7 +18680,7 @@
           </a:ln>
           <a:extLst>
             <a:ext uri="{C572A759-6A51-4108-AA02-DFA0A04FC94B}">
-              <ma14:wrappingTextBoxFlag xmlns="" xmlns:m="http://schemas.openxmlformats.org/officeDocument/2006/math" xmlns:a14="http://schemas.microsoft.com/office/drawing/2010/main" xmlns:ma14="http://schemas.microsoft.com/office/mac/drawingml/2011/main" val="1"/>
+              <ma14:wrappingTextBoxFlag xmlns:ma14="http://schemas.microsoft.com/office/mac/drawingml/2011/main" xmlns:a14="http://schemas.microsoft.com/office/drawing/2010/main" xmlns:m="http://schemas.openxmlformats.org/officeDocument/2006/math" xmlns="" val="1"/>
             </a:ext>
           </a:extLst>
         </p:spPr>
@@ -18722,7 +18734,7 @@
           </a:ln>
           <a:extLst>
             <a:ext uri="{C572A759-6A51-4108-AA02-DFA0A04FC94B}">
-              <ma14:wrappingTextBoxFlag xmlns="" xmlns:m="http://schemas.openxmlformats.org/officeDocument/2006/math" xmlns:a14="http://schemas.microsoft.com/office/drawing/2010/main" xmlns:ma14="http://schemas.microsoft.com/office/mac/drawingml/2011/main" val="1"/>
+              <ma14:wrappingTextBoxFlag xmlns:ma14="http://schemas.microsoft.com/office/mac/drawingml/2011/main" xmlns:a14="http://schemas.microsoft.com/office/drawing/2010/main" xmlns:m="http://schemas.openxmlformats.org/officeDocument/2006/math" xmlns="" val="1"/>
             </a:ext>
           </a:extLst>
         </p:spPr>
@@ -19072,7 +19084,7 @@
           </a:ln>
           <a:extLst>
             <a:ext uri="{C572A759-6A51-4108-AA02-DFA0A04FC94B}">
-              <ma14:wrappingTextBoxFlag xmlns="" xmlns:m="http://schemas.openxmlformats.org/officeDocument/2006/math" xmlns:a14="http://schemas.microsoft.com/office/drawing/2010/main" xmlns:ma14="http://schemas.microsoft.com/office/mac/drawingml/2011/main" val="1"/>
+              <ma14:wrappingTextBoxFlag xmlns:ma14="http://schemas.microsoft.com/office/mac/drawingml/2011/main" xmlns:a14="http://schemas.microsoft.com/office/drawing/2010/main" xmlns:m="http://schemas.openxmlformats.org/officeDocument/2006/math" xmlns="" val="1"/>
             </a:ext>
           </a:extLst>
         </p:spPr>
@@ -19175,7 +19187,7 @@
           </a:ln>
           <a:extLst>
             <a:ext uri="{C572A759-6A51-4108-AA02-DFA0A04FC94B}">
-              <ma14:wrappingTextBoxFlag xmlns="" xmlns:m="http://schemas.openxmlformats.org/officeDocument/2006/math" xmlns:a14="http://schemas.microsoft.com/office/drawing/2010/main" xmlns:ma14="http://schemas.microsoft.com/office/mac/drawingml/2011/main" val="1"/>
+              <ma14:wrappingTextBoxFlag xmlns:ma14="http://schemas.microsoft.com/office/mac/drawingml/2011/main" xmlns:a14="http://schemas.microsoft.com/office/drawing/2010/main" xmlns:m="http://schemas.openxmlformats.org/officeDocument/2006/math" xmlns="" val="1"/>
             </a:ext>
           </a:extLst>
         </p:spPr>
@@ -19377,7 +19389,7 @@
           </a:ln>
           <a:extLst>
             <a:ext uri="{C572A759-6A51-4108-AA02-DFA0A04FC94B}">
-              <ma14:wrappingTextBoxFlag xmlns="" xmlns:m="http://schemas.openxmlformats.org/officeDocument/2006/math" xmlns:a14="http://schemas.microsoft.com/office/drawing/2010/main" xmlns:ma14="http://schemas.microsoft.com/office/mac/drawingml/2011/main" val="1"/>
+              <ma14:wrappingTextBoxFlag xmlns:ma14="http://schemas.microsoft.com/office/mac/drawingml/2011/main" xmlns:a14="http://schemas.microsoft.com/office/drawing/2010/main" xmlns:m="http://schemas.openxmlformats.org/officeDocument/2006/math" xmlns="" val="1"/>
             </a:ext>
           </a:extLst>
         </p:spPr>
@@ -19604,7 +19616,7 @@
           </a:ln>
           <a:extLst>
             <a:ext uri="{C572A759-6A51-4108-AA02-DFA0A04FC94B}">
-              <ma14:wrappingTextBoxFlag xmlns="" xmlns:m="http://schemas.openxmlformats.org/officeDocument/2006/math" xmlns:a14="http://schemas.microsoft.com/office/drawing/2010/main" xmlns:ma14="http://schemas.microsoft.com/office/mac/drawingml/2011/main" val="1"/>
+              <ma14:wrappingTextBoxFlag xmlns:ma14="http://schemas.microsoft.com/office/mac/drawingml/2011/main" xmlns:a14="http://schemas.microsoft.com/office/drawing/2010/main" xmlns:m="http://schemas.openxmlformats.org/officeDocument/2006/math" xmlns="" val="1"/>
             </a:ext>
           </a:extLst>
         </p:spPr>
@@ -20089,7 +20101,7 @@
           </a:ln>
           <a:extLst>
             <a:ext uri="{C572A759-6A51-4108-AA02-DFA0A04FC94B}">
-              <ma14:wrappingTextBoxFlag xmlns="" xmlns:m="http://schemas.openxmlformats.org/officeDocument/2006/math" xmlns:a14="http://schemas.microsoft.com/office/drawing/2010/main" xmlns:ma14="http://schemas.microsoft.com/office/mac/drawingml/2011/main" val="1"/>
+              <ma14:wrappingTextBoxFlag xmlns:ma14="http://schemas.microsoft.com/office/mac/drawingml/2011/main" xmlns:a14="http://schemas.microsoft.com/office/drawing/2010/main" xmlns:m="http://schemas.openxmlformats.org/officeDocument/2006/math" xmlns="" val="1"/>
             </a:ext>
           </a:extLst>
         </p:spPr>
@@ -20137,7 +20149,7 @@
           </a:ln>
           <a:extLst>
             <a:ext uri="{C572A759-6A51-4108-AA02-DFA0A04FC94B}">
-              <ma14:wrappingTextBoxFlag xmlns="" xmlns:m="http://schemas.openxmlformats.org/officeDocument/2006/math" xmlns:a14="http://schemas.microsoft.com/office/drawing/2010/main" xmlns:ma14="http://schemas.microsoft.com/office/mac/drawingml/2011/main" val="1"/>
+              <ma14:wrappingTextBoxFlag xmlns:ma14="http://schemas.microsoft.com/office/mac/drawingml/2011/main" xmlns:a14="http://schemas.microsoft.com/office/drawing/2010/main" xmlns:m="http://schemas.openxmlformats.org/officeDocument/2006/math" xmlns="" val="1"/>
             </a:ext>
           </a:extLst>
         </p:spPr>
@@ -20185,7 +20197,7 @@
           </a:ln>
           <a:extLst>
             <a:ext uri="{C572A759-6A51-4108-AA02-DFA0A04FC94B}">
-              <ma14:wrappingTextBoxFlag xmlns="" xmlns:m="http://schemas.openxmlformats.org/officeDocument/2006/math" xmlns:a14="http://schemas.microsoft.com/office/drawing/2010/main" xmlns:ma14="http://schemas.microsoft.com/office/mac/drawingml/2011/main" val="1"/>
+              <ma14:wrappingTextBoxFlag xmlns:ma14="http://schemas.microsoft.com/office/mac/drawingml/2011/main" xmlns:a14="http://schemas.microsoft.com/office/drawing/2010/main" xmlns:m="http://schemas.openxmlformats.org/officeDocument/2006/math" xmlns="" val="1"/>
             </a:ext>
           </a:extLst>
         </p:spPr>
@@ -20233,7 +20245,7 @@
           </a:ln>
           <a:extLst>
             <a:ext uri="{C572A759-6A51-4108-AA02-DFA0A04FC94B}">
-              <ma14:wrappingTextBoxFlag xmlns="" xmlns:m="http://schemas.openxmlformats.org/officeDocument/2006/math" xmlns:a14="http://schemas.microsoft.com/office/drawing/2010/main" xmlns:ma14="http://schemas.microsoft.com/office/mac/drawingml/2011/main" val="1"/>
+              <ma14:wrappingTextBoxFlag xmlns:ma14="http://schemas.microsoft.com/office/mac/drawingml/2011/main" xmlns:a14="http://schemas.microsoft.com/office/drawing/2010/main" xmlns:m="http://schemas.openxmlformats.org/officeDocument/2006/math" xmlns="" val="1"/>
             </a:ext>
           </a:extLst>
         </p:spPr>
@@ -20281,7 +20293,7 @@
           </a:ln>
           <a:extLst>
             <a:ext uri="{C572A759-6A51-4108-AA02-DFA0A04FC94B}">
-              <ma14:wrappingTextBoxFlag xmlns="" xmlns:m="http://schemas.openxmlformats.org/officeDocument/2006/math" xmlns:a14="http://schemas.microsoft.com/office/drawing/2010/main" xmlns:ma14="http://schemas.microsoft.com/office/mac/drawingml/2011/main" val="1"/>
+              <ma14:wrappingTextBoxFlag xmlns:ma14="http://schemas.microsoft.com/office/mac/drawingml/2011/main" xmlns:a14="http://schemas.microsoft.com/office/drawing/2010/main" xmlns:m="http://schemas.openxmlformats.org/officeDocument/2006/math" xmlns="" val="1"/>
             </a:ext>
           </a:extLst>
         </p:spPr>
@@ -21234,7 +21246,7 @@
           </a:ln>
           <a:extLst>
             <a:ext uri="{C572A759-6A51-4108-AA02-DFA0A04FC94B}">
-              <ma14:wrappingTextBoxFlag xmlns="" xmlns:m="http://schemas.openxmlformats.org/officeDocument/2006/math" xmlns:a14="http://schemas.microsoft.com/office/drawing/2010/main" xmlns:ma14="http://schemas.microsoft.com/office/mac/drawingml/2011/main" val="1"/>
+              <ma14:wrappingTextBoxFlag xmlns:ma14="http://schemas.microsoft.com/office/mac/drawingml/2011/main" xmlns:a14="http://schemas.microsoft.com/office/drawing/2010/main" xmlns:m="http://schemas.openxmlformats.org/officeDocument/2006/math" xmlns="" val="1"/>
             </a:ext>
           </a:extLst>
         </p:spPr>
@@ -21536,7 +21548,7 @@
           </a:ln>
           <a:extLst>
             <a:ext uri="{C572A759-6A51-4108-AA02-DFA0A04FC94B}">
-              <ma14:wrappingTextBoxFlag xmlns="" xmlns:m="http://schemas.openxmlformats.org/officeDocument/2006/math" xmlns:a14="http://schemas.microsoft.com/office/drawing/2010/main" xmlns:ma14="http://schemas.microsoft.com/office/mac/drawingml/2011/main" val="1"/>
+              <ma14:wrappingTextBoxFlag xmlns:ma14="http://schemas.microsoft.com/office/mac/drawingml/2011/main" xmlns:a14="http://schemas.microsoft.com/office/drawing/2010/main" xmlns:m="http://schemas.openxmlformats.org/officeDocument/2006/math" xmlns="" val="1"/>
             </a:ext>
           </a:extLst>
         </p:spPr>
@@ -23118,7 +23130,7 @@
           </a:ln>
           <a:extLst>
             <a:ext uri="{C572A759-6A51-4108-AA02-DFA0A04FC94B}">
-              <ma14:wrappingTextBoxFlag xmlns="" xmlns:m="http://schemas.openxmlformats.org/officeDocument/2006/math" xmlns:a14="http://schemas.microsoft.com/office/drawing/2010/main" xmlns:ma14="http://schemas.microsoft.com/office/mac/drawingml/2011/main" val="1"/>
+              <ma14:wrappingTextBoxFlag xmlns:ma14="http://schemas.microsoft.com/office/mac/drawingml/2011/main" xmlns:a14="http://schemas.microsoft.com/office/drawing/2010/main" xmlns:m="http://schemas.openxmlformats.org/officeDocument/2006/math" xmlns="" val="1"/>
             </a:ext>
           </a:extLst>
         </p:spPr>

</xml_diff>